<commit_message>
Add the Random Forest reweighting bug to the Challenges slide
One short bullet, placed second so it sits beside the Spark environment bugs and
contrasts with them: those four were not our logic, this one was. Deliberately
brief - the presenter covers the rest verbally (over-corrected nine times past
balance, minority-class overfitting, 1.8 points of ROC-AUC, and the model choice
becoming a tie decided on other grounds).

The slide had 2.42in of headroom, so no resizing was needed; six bullets end at
5.85in and the layout check reports no collisions across all 19 slides.

Co-Authored-By: Claude Opus 5 <noreply@anthropic.com>
</commit_message>
<xml_diff>
--- a/docs/slides/slides.pptx
+++ b/docs/slides/slides.pptx
@@ -11208,6 +11208,22 @@
             </a:pPr>
             <a:r>
               <a:t>•  Windows + Spark: worker Python resolution, a path with spaces, a pyspark 3.5.1 / Python 3.12 incompatibility, and a removed distutils — four environment bugs, none in our own logic, all diagnosed and fixed rather than worked around.</a:t>
+            </a:r>
+          </a:p>
+          <a:p>
+            <a:pPr>
+              <a:spcAft>
+                <a:spcPts val="1200"/>
+              </a:spcAft>
+              <a:defRPr sz="1800">
+                <a:solidFill>
+                  <a:srgbClr val="1A202C"/>
+                </a:solidFill>
+                <a:latin typeface="Calibri"/>
+              </a:defRPr>
+            </a:pPr>
+            <a:r>
+              <a:t>•  A bug in our own code: Random Forest was reweighted twice — class_weight and sample_weight multiply in sklearn, turning 8.8:1 into 78:1.</a:t>
             </a:r>
           </a:p>
           <a:p>

</xml_diff>